<commit_message>
Update documentation and enhance clarity for PD18 research notebook
- Introduced `PD18_Assortative_Formation_Literature_and_Modeling_Notebook.md` as a living research document detailing the project’s immediate research questions and design locks.
- Added `01_forward_plan_reading_guide.md` and `02_Charles_decisions_locked.md` to provide structured guidance on reading order and decision locks for agents.
- Updated `README.txt` to clarify the organization of the `3-Master_Plan/` directory and highlight key documents for user reference.
- Enhanced `statistics.json` to reflect the latest user and agent message counts, ensuring accurate tracking of project activity.

These changes improve the organization and clarity of the documentation, facilitating better understanding and execution of the PD18 characterization mission.
</commit_message>
<xml_diff>
--- a/3-Master_Plan/re_entry/HEROs_and_PASSes/slides/PASS_ABC_Gallery_Slides.pptx
+++ b/3-Master_Plan/re_entry/HEROs_and_PASSes/slides/PASS_ABC_Gallery_Slides.pptx
@@ -3138,8 +3138,8 @@
         </p:blipFill>
         <p:spPr>
           <a:xfrm>
-            <a:off x="1228179" y="841248"/>
-            <a:ext cx="9735337" cy="3794761"/>
+            <a:off x="1225449" y="841248"/>
+            <a:ext cx="9740797" cy="3794761"/>
           </a:xfrm>
           <a:prstGeom prst="rect">
             <a:avLst/>
@@ -3862,8 +3862,8 @@
         </p:blipFill>
         <p:spPr>
           <a:xfrm>
-            <a:off x="3146329" y="841248"/>
-            <a:ext cx="5899036" cy="3794760"/>
+            <a:off x="3266718" y="841248"/>
+            <a:ext cx="5658259" cy="3794761"/>
           </a:xfrm>
           <a:prstGeom prst="rect">
             <a:avLst/>
@@ -3878,8 +3878,8 @@
         </p:nvSpPr>
         <p:spPr>
           <a:xfrm>
-            <a:off x="411480" y="4764024"/>
-            <a:ext cx="5570067" cy="1335024"/>
+            <a:off x="411480" y="4764025"/>
+            <a:ext cx="5570067" cy="1335023"/>
           </a:xfrm>
           <a:prstGeom prst="rect">
             <a:avLst/>
@@ -4009,8 +4009,8 @@
         </p:nvSpPr>
         <p:spPr>
           <a:xfrm>
-            <a:off x="6210147" y="4764024"/>
-            <a:ext cx="5570067" cy="1335024"/>
+            <a:off x="6210147" y="4764025"/>
+            <a:ext cx="5570067" cy="1335023"/>
           </a:xfrm>
           <a:prstGeom prst="rect">
             <a:avLst/>

</xml_diff>

<commit_message>
Refactor MLE documentation and enhance fitting parameter resources
- Moved MLE-related documents to a dedicated folder for better organization, including `MLE_basics.md` and `MLE_fit_explainer.md`.
- Added new markdown files detailing the fitting process for parameters such as lambda, gamma, and temperature, enhancing instructional clarity.
- Introduced a PDF document summarizing the MLE fitting process for easier reference.
- Updated existing scripts and JSON files to reflect the latest fitting methodologies and results, ensuring accurate tracking of parameter values.

These changes improve the structure and accessibility of MLE resources, supporting ongoing analysis and understanding of the fitting process.
</commit_message>
<xml_diff>
--- a/3-Master_Plan/re_entry/HEROs_and_PASSes/slides/PASS_ABC_Gallery_Slides.pptx
+++ b/3-Master_Plan/re_entry/HEROs_and_PASSes/slides/PASS_ABC_Gallery_Slides.pptx
@@ -3138,8 +3138,8 @@
         </p:blipFill>
         <p:spPr>
           <a:xfrm>
-            <a:off x="1225449" y="841248"/>
-            <a:ext cx="9740797" cy="3794761"/>
+            <a:off x="1145084" y="841248"/>
+            <a:ext cx="9901526" cy="3794761"/>
           </a:xfrm>
           <a:prstGeom prst="rect">
             <a:avLst/>
@@ -3178,7 +3178,7 @@
             </a:pPr>
             <a:r>
               <a:rPr sz="1100"/>
-              <a:t>Real NCAA panel (2011–2021): mean NBA draft rate by ventile.</a:t>
+              <a:t>Real NCAA panel (2011-2021): mean NBA draft rate by ventile.</a:t>
             </a:r>
           </a:p>
           <a:p>
@@ -3216,29 +3216,7 @@
             </a:pPr>
             <a:r>
               <a:rPr sz="1100"/>
-              <a:t>Right — roster context: leave-one-out teammate quality (</a:t>
-            </a:r>
-            <a:r>
-              <a:rPr sz="1100" i="1">
-                <a:latin typeface="Cambria Math"/>
-              </a:rPr>
-              <a:t>poolq\</a:t>
-            </a:r>
-            <a:r>
-              <a:rPr sz="900" i="1" baseline="-25000">
-                <a:latin typeface="Cambria Math"/>
-              </a:rPr>
-              <a:t>l</a:t>
-            </a:r>
-            <a:r>
-              <a:rPr sz="1100" i="1">
-                <a:latin typeface="Cambria Math"/>
-              </a:rPr>
-              <a:t>oo</a:t>
-            </a:r>
-            <a:r>
-              <a:rPr sz="1100"/>
-              <a:t>). Inverted-U.</a:t>
+              <a:t>Right — roster context: middle rise; flat elite tail on POST-QC panel.</a:t>
             </a:r>
           </a:p>
         </p:txBody>
@@ -3285,7 +3263,7 @@
             </a:r>
             <a:r>
               <a:rPr sz="1100"/>
-              <a:t> in the empirical story — stylized fact Pass B/C echo.</a:t>
+              <a:t> in the empirical story — generative Pass B/C show inverted-U in sim.</a:t>
             </a:r>
           </a:p>
           <a:p>
@@ -3862,8 +3840,8 @@
         </p:blipFill>
         <p:spPr>
           <a:xfrm>
-            <a:off x="3266718" y="841248"/>
-            <a:ext cx="5658259" cy="3794761"/>
+            <a:off x="3207153" y="841248"/>
+            <a:ext cx="5777389" cy="3794760"/>
           </a:xfrm>
           <a:prstGeom prst="rect">
             <a:avLst/>
@@ -3878,8 +3856,8 @@
         </p:nvSpPr>
         <p:spPr>
           <a:xfrm>
-            <a:off x="411480" y="4764025"/>
-            <a:ext cx="5570067" cy="1335023"/>
+            <a:off x="411480" y="4764024"/>
+            <a:ext cx="5570067" cy="1335024"/>
           </a:xfrm>
           <a:prstGeom prst="rect">
             <a:avLst/>
@@ -4009,8 +3987,8 @@
         </p:nvSpPr>
         <p:spPr>
           <a:xfrm>
-            <a:off x="6210147" y="4764025"/>
-            <a:ext cx="5570067" cy="1335023"/>
+            <a:off x="6210147" y="4764024"/>
+            <a:ext cx="5570067" cy="1335024"/>
           </a:xfrm>
           <a:prstGeom prst="rect">
             <a:avLst/>

</xml_diff>